<commit_message>
Actualiza el conteo de pruebas en la documentacion (269)
</commit_message>
<xml_diff>
--- a/entrega/GOSS_IP_Presentacion_Fase2.pptx
+++ b/entrega/GOSS_IP_Presentacion_Fase2.pptx
@@ -613,7 +613,7 @@
           </a:p>
           <a:p>
             <a:r>
-              <a:t>Tenemos 267 pruebas automáticas que corren en Windows y Linux en cada cambio.</a:t>
+              <a:t>Tenemos 269 pruebas automáticas que corren en Windows y Linux en cada cambio.</a:t>
             </a:r>
           </a:p>
           <a:p>
@@ -1083,7 +1083,7 @@
           <a:lstStyle/>
           <a:p>
             <a:r>
-              <a:t>Anexo del recomendador de instalación. La norma IEC 62676-4 define niveles por píxeles por metro: detección 25, observación 62.5, reconocimiento 125, identificación 250. Lo combinamos con nuestros umbrales medidos: placa 36 px y rostro 50 px, y pedimos el doble para instalar.</a:t>
+              <a:t>Anexo del recomendador de instalación. La norma IEC 62696-4 define niveles por píxeles por metro: detección 25, observación 62.5, reconocimiento 125, identificación 250. Lo combinamos con nuestros umbrales medidos: placa 36 px y rostro 50 px, y pedimos el doble para instalar.</a:t>
             </a:r>
           </a:p>
         </p:txBody>
@@ -5691,7 +5691,7 @@
                 </a:solidFill>
                 <a:latin typeface="Segoe UI Semibold"/>
               </a:rPr>
-              <a:t>267</a:t>
+              <a:t>269</a:t>
             </a:r>
           </a:p>
         </p:txBody>
@@ -10527,7 +10527,7 @@
                           </a:solidFill>
                           <a:latin typeface="Segoe UI Semibold"/>
                         </a:rPr>
-                        <a:t>Nivel DORI (IEC 62676-4)</a:t>
+                        <a:t>Nivel DORI (IEC 62696-4)</a:t>
                       </a:r>
                     </a:p>
                   </a:txBody>

</xml_diff>

<commit_message>
Documentacion de la Fase 2 al 7 de octubre
- Memoria tecnica: funciones nuevas, mediciones con las camaras reales,
  respaldo probado, arquitectura hibrida y control de cambios por commit;
  corrige la norma DORI (IEC 62676-4)
- Portafolio de evidencias: pruebas, validaciones, metricas y mejoras, cada
  una con su archivo y como reproducirla
- Bitacora del Bootcamp: sesiones de los tres dias con su vinculo al
  proyecto, control de cambios, respaldo fechado, ensayos y la lista final
  de verificacion de los lineamientos
- Presentacion: 277 pruebas, alerta de rostro, escalamiento hibrido y la
  norma DORI corregida
</commit_message>
<xml_diff>
--- a/entrega/GOSS_IP_Presentacion_Fase2.pptx
+++ b/entrega/GOSS_IP_Presentacion_Fase2.pptx
@@ -613,7 +613,7 @@
           </a:p>
           <a:p>
             <a:r>
-              <a:t>Tenemos 269 pruebas automáticas que corren en Windows y Linux en cada cambio.</a:t>
+              <a:t>Tenemos 277 pruebas automáticas que corren en Windows y Linux en cada cambio. Y con las dos cámaras del stand, cada una con placas y rostros, cada una analiza cerca de 8 cuadros por segundo (7.4 y 7.7) con la GPU al 38 %.</a:t>
             </a:r>
           </a:p>
           <a:p>
@@ -778,7 +778,7 @@
           </a:p>
           <a:p>
             <a:r>
-              <a:t>Para crecer: un nodo más por cada dos cámaras con todo activo, o más cámaras por nodo si solo leen placas; la API escala con PostgreSQL y Redis y se despliega con Docker.</a:t>
+              <a:t>Para crecer: un nodo más por cada dos cámaras con todo activo, o más cámaras por nodo si solo leen placas. El video siempre se procesa en el sitio; lo que puede ir a un servidor central o a la nube, con Docker, es la API, la lista negra maestra que comparten los centros de mando y el respaldo diario.</a:t>
             </a:r>
           </a:p>
         </p:txBody>
@@ -1083,7 +1083,7 @@
           <a:lstStyle/>
           <a:p>
             <a:r>
-              <a:t>Anexo del recomendador de instalación. La norma IEC 62696-4 define niveles por píxeles por metro: detección 25, observación 62.5, reconocimiento 125, identificación 250. Lo combinamos con nuestros umbrales medidos: placa 36 px y rostro 50 px, y pedimos el doble para instalar.</a:t>
+              <a:t>Anexo del recomendador de instalación. La norma IEC 62676-4 define niveles por píxeles por metro: detección 25, observación 62.5, reconocimiento 125, identificación 250. Lo combinamos con nuestros umbrales medidos: placa 36 px y rostro 50 px, y pedimos el doble para instalar.</a:t>
             </a:r>
           </a:p>
         </p:txBody>
@@ -1573,7 +1573,7 @@
           </a:p>
           <a:p>
             <a:r>
-              <a:t>Rostros: funciona, pero el umbral es el de fábrica; falta calibrarlo con personas reales y su consentimiento.</a:t>
+              <a:t>Rostros: funciona y la alerta sale en cuanto la persona da la cara, alrededor de un segundo, sin esperar a que se vaya; el umbral es el de fábrica y falta calibrarlo con personas reales y su consentimiento.</a:t>
             </a:r>
           </a:p>
           <a:p>
@@ -5691,7 +5691,7 @@
                 </a:solidFill>
                 <a:latin typeface="Segoe UI Semibold"/>
               </a:rPr>
-              <a:t>269</a:t>
+              <a:t>277</a:t>
             </a:r>
           </a:p>
         </p:txBody>
@@ -8571,7 +8571,7 @@
                 </a:solidFill>
                 <a:latin typeface="Segoe UI"/>
               </a:rPr>
-              <a:t>API en varios procesos con PostgreSQL y Redis.</a:t>
+              <a:t>Video en el sitio; API, lista negra maestra y respaldo, centrales (Docker).</a:t>
             </a:r>
           </a:p>
           <a:p>
@@ -8599,7 +8599,7 @@
                 </a:solidFill>
                 <a:latin typeface="Segoe UI"/>
               </a:rPr>
-              <a:t>Despliegue con Docker y HTTPS.</a:t>
+              <a:t>Respaldo en la nube: restauración probada.</a:t>
             </a:r>
           </a:p>
         </p:txBody>
@@ -10527,7 +10527,7 @@
                           </a:solidFill>
                           <a:latin typeface="Segoe UI Semibold"/>
                         </a:rPr>
-                        <a:t>Nivel DORI (IEC 62696-4)</a:t>
+                        <a:t>Nivel DORI (IEC 62676-4)</a:t>
                       </a:r>
                     </a:p>
                   </a:txBody>
@@ -15742,7 +15742,7 @@
                 </a:solidFill>
                 <a:latin typeface="Segoe UI"/>
               </a:rPr>
-              <a:t>Solo lista negra · umbral por calibrar</a:t>
+              <a:t>Alerta en ~1 s de frente · umbral por calibrar</a:t>
             </a:r>
           </a:p>
         </p:txBody>
@@ -16567,7 +16567,7 @@
                 </a:solidFill>
                 <a:latin typeface="Segoe UI"/>
               </a:rPr>
-              <a:t>Telegram, correo, WhatsApp</a:t>
+              <a:t>Telegram (probado), correo, WhatsApp</a:t>
             </a:r>
           </a:p>
         </p:txBody>

</xml_diff>